<commit_message>
Sync important dates and update presentation template
</commit_message>
<xml_diff>
--- a/assets/documents/IPRECON_2026_Conference_Template.pptx
+++ b/assets/documents/IPRECON_2026_Conference_Template.pptx
@@ -126,19 +126,19 @@
 <pc:chgInfo xmlns:a="http://schemas.openxmlformats.org/drawingml/2006/main" xmlns:r="http://schemas.openxmlformats.org/officeDocument/2006/relationships" xmlns:ac="http://schemas.microsoft.com/office/drawing/2013/main/command" xmlns:pc="http://schemas.microsoft.com/office/powerpoint/2013/main/command">
   <pc:docChgLst>
     <pc:chgData name="Cliffin Cletus" userId="143810bfc296b747" providerId="LiveId" clId="{7F3DFCB6-D3EC-49C4-9130-F6BA86D7608E}"/>
-    <pc:docChg chg="undo custSel modSld">
-      <pc:chgData name="Cliffin Cletus" userId="143810bfc296b747" providerId="LiveId" clId="{7F3DFCB6-D3EC-49C4-9130-F6BA86D7608E}" dt="2026-07-24T14:00:10.610" v="102" actId="20577"/>
+    <pc:docChg chg="undo redo custSel addSld delSld modSld">
+      <pc:chgData name="Cliffin Cletus" userId="143810bfc296b747" providerId="LiveId" clId="{7F3DFCB6-D3EC-49C4-9130-F6BA86D7608E}" dt="2026-07-24T14:56:41.606" v="220" actId="20577"/>
       <pc:docMkLst>
         <pc:docMk/>
       </pc:docMkLst>
       <pc:sldChg chg="modSp mod">
-        <pc:chgData name="Cliffin Cletus" userId="143810bfc296b747" providerId="LiveId" clId="{7F3DFCB6-D3EC-49C4-9130-F6BA86D7608E}" dt="2026-07-24T13:58:59.385" v="86" actId="1035"/>
+        <pc:chgData name="Cliffin Cletus" userId="143810bfc296b747" providerId="LiveId" clId="{7F3DFCB6-D3EC-49C4-9130-F6BA86D7608E}" dt="2026-07-24T14:56:41.606" v="220" actId="20577"/>
         <pc:sldMkLst>
           <pc:docMk/>
           <pc:sldMk cId="0" sldId="256"/>
         </pc:sldMkLst>
         <pc:spChg chg="mod">
-          <ac:chgData name="Cliffin Cletus" userId="143810bfc296b747" providerId="LiveId" clId="{7F3DFCB6-D3EC-49C4-9130-F6BA86D7608E}" dt="2026-07-24T13:58:59.385" v="86" actId="1035"/>
+          <ac:chgData name="Cliffin Cletus" userId="143810bfc296b747" providerId="LiveId" clId="{7F3DFCB6-D3EC-49C4-9130-F6BA86D7608E}" dt="2026-07-24T14:56:41.606" v="220" actId="20577"/>
           <ac:spMkLst>
             <pc:docMk/>
             <pc:sldMk cId="0" sldId="256"/>
@@ -147,13 +147,13 @@
         </pc:spChg>
       </pc:sldChg>
       <pc:sldChg chg="modSp mod">
-        <pc:chgData name="Cliffin Cletus" userId="143810bfc296b747" providerId="LiveId" clId="{7F3DFCB6-D3EC-49C4-9130-F6BA86D7608E}" dt="2026-07-24T13:59:06.475" v="87" actId="1035"/>
+        <pc:chgData name="Cliffin Cletus" userId="143810bfc296b747" providerId="LiveId" clId="{7F3DFCB6-D3EC-49C4-9130-F6BA86D7608E}" dt="2026-07-24T14:56:31.589" v="214" actId="20577"/>
         <pc:sldMkLst>
           <pc:docMk/>
           <pc:sldMk cId="0" sldId="257"/>
         </pc:sldMkLst>
         <pc:spChg chg="mod">
-          <ac:chgData name="Cliffin Cletus" userId="143810bfc296b747" providerId="LiveId" clId="{7F3DFCB6-D3EC-49C4-9130-F6BA86D7608E}" dt="2026-07-24T13:59:06.475" v="87" actId="1035"/>
+          <ac:chgData name="Cliffin Cletus" userId="143810bfc296b747" providerId="LiveId" clId="{7F3DFCB6-D3EC-49C4-9130-F6BA86D7608E}" dt="2026-07-24T14:56:31.589" v="214" actId="20577"/>
           <ac:spMkLst>
             <pc:docMk/>
             <pc:sldMk cId="0" sldId="257"/>
@@ -162,7 +162,7 @@
         </pc:spChg>
       </pc:sldChg>
       <pc:sldChg chg="modSp mod">
-        <pc:chgData name="Cliffin Cletus" userId="143810bfc296b747" providerId="LiveId" clId="{7F3DFCB6-D3EC-49C4-9130-F6BA86D7608E}" dt="2026-07-24T14:00:10.610" v="102" actId="20577"/>
+        <pc:chgData name="Cliffin Cletus" userId="143810bfc296b747" providerId="LiveId" clId="{7F3DFCB6-D3EC-49C4-9130-F6BA86D7608E}" dt="2026-07-24T14:56:24.386" v="208" actId="20577"/>
         <pc:sldMkLst>
           <pc:docMk/>
           <pc:sldMk cId="0" sldId="258"/>
@@ -176,7 +176,7 @@
           </ac:spMkLst>
         </pc:spChg>
         <pc:spChg chg="mod">
-          <ac:chgData name="Cliffin Cletus" userId="143810bfc296b747" providerId="LiveId" clId="{7F3DFCB6-D3EC-49C4-9130-F6BA86D7608E}" dt="2026-07-24T13:59:13.344" v="88" actId="1035"/>
+          <ac:chgData name="Cliffin Cletus" userId="143810bfc296b747" providerId="LiveId" clId="{7F3DFCB6-D3EC-49C4-9130-F6BA86D7608E}" dt="2026-07-24T14:56:24.386" v="208" actId="20577"/>
           <ac:spMkLst>
             <pc:docMk/>
             <pc:sldMk cId="0" sldId="258"/>
@@ -185,13 +185,13 @@
         </pc:spChg>
       </pc:sldChg>
       <pc:sldChg chg="modSp mod">
-        <pc:chgData name="Cliffin Cletus" userId="143810bfc296b747" providerId="LiveId" clId="{7F3DFCB6-D3EC-49C4-9130-F6BA86D7608E}" dt="2026-07-24T13:59:24.541" v="89" actId="1035"/>
+        <pc:chgData name="Cliffin Cletus" userId="143810bfc296b747" providerId="LiveId" clId="{7F3DFCB6-D3EC-49C4-9130-F6BA86D7608E}" dt="2026-07-24T14:56:12.961" v="202" actId="20577"/>
         <pc:sldMkLst>
           <pc:docMk/>
           <pc:sldMk cId="0" sldId="259"/>
         </pc:sldMkLst>
         <pc:spChg chg="mod">
-          <ac:chgData name="Cliffin Cletus" userId="143810bfc296b747" providerId="LiveId" clId="{7F3DFCB6-D3EC-49C4-9130-F6BA86D7608E}" dt="2026-07-24T13:59:24.541" v="89" actId="1035"/>
+          <ac:chgData name="Cliffin Cletus" userId="143810bfc296b747" providerId="LiveId" clId="{7F3DFCB6-D3EC-49C4-9130-F6BA86D7608E}" dt="2026-07-24T14:56:12.961" v="202" actId="20577"/>
           <ac:spMkLst>
             <pc:docMk/>
             <pc:sldMk cId="0" sldId="259"/>
@@ -200,13 +200,13 @@
         </pc:spChg>
       </pc:sldChg>
       <pc:sldChg chg="modSp mod">
-        <pc:chgData name="Cliffin Cletus" userId="143810bfc296b747" providerId="LiveId" clId="{7F3DFCB6-D3EC-49C4-9130-F6BA86D7608E}" dt="2026-07-24T13:59:30.920" v="90" actId="1035"/>
+        <pc:chgData name="Cliffin Cletus" userId="143810bfc296b747" providerId="LiveId" clId="{7F3DFCB6-D3EC-49C4-9130-F6BA86D7608E}" dt="2026-07-24T14:56:01.059" v="196" actId="14100"/>
         <pc:sldMkLst>
           <pc:docMk/>
           <pc:sldMk cId="0" sldId="260"/>
         </pc:sldMkLst>
         <pc:spChg chg="mod">
-          <ac:chgData name="Cliffin Cletus" userId="143810bfc296b747" providerId="LiveId" clId="{7F3DFCB6-D3EC-49C4-9130-F6BA86D7608E}" dt="2026-07-24T13:59:30.920" v="90" actId="1035"/>
+          <ac:chgData name="Cliffin Cletus" userId="143810bfc296b747" providerId="LiveId" clId="{7F3DFCB6-D3EC-49C4-9130-F6BA86D7608E}" dt="2026-07-24T14:56:01.059" v="196" actId="14100"/>
           <ac:spMkLst>
             <pc:docMk/>
             <pc:sldMk cId="0" sldId="260"/>
@@ -215,13 +215,13 @@
         </pc:spChg>
       </pc:sldChg>
       <pc:sldChg chg="modSp mod">
-        <pc:chgData name="Cliffin Cletus" userId="143810bfc296b747" providerId="LiveId" clId="{7F3DFCB6-D3EC-49C4-9130-F6BA86D7608E}" dt="2026-07-24T13:59:35.256" v="91" actId="1035"/>
+        <pc:chgData name="Cliffin Cletus" userId="143810bfc296b747" providerId="LiveId" clId="{7F3DFCB6-D3EC-49C4-9130-F6BA86D7608E}" dt="2026-07-24T14:55:48.853" v="189" actId="20577"/>
         <pc:sldMkLst>
           <pc:docMk/>
           <pc:sldMk cId="0" sldId="261"/>
         </pc:sldMkLst>
         <pc:spChg chg="mod">
-          <ac:chgData name="Cliffin Cletus" userId="143810bfc296b747" providerId="LiveId" clId="{7F3DFCB6-D3EC-49C4-9130-F6BA86D7608E}" dt="2026-07-24T13:59:35.256" v="91" actId="1035"/>
+          <ac:chgData name="Cliffin Cletus" userId="143810bfc296b747" providerId="LiveId" clId="{7F3DFCB6-D3EC-49C4-9130-F6BA86D7608E}" dt="2026-07-24T14:55:48.853" v="189" actId="20577"/>
           <ac:spMkLst>
             <pc:docMk/>
             <pc:sldMk cId="0" sldId="261"/>
@@ -230,13 +230,13 @@
         </pc:spChg>
       </pc:sldChg>
       <pc:sldChg chg="modSp mod">
-        <pc:chgData name="Cliffin Cletus" userId="143810bfc296b747" providerId="LiveId" clId="{7F3DFCB6-D3EC-49C4-9130-F6BA86D7608E}" dt="2026-07-24T13:59:39.535" v="92" actId="1035"/>
+        <pc:chgData name="Cliffin Cletus" userId="143810bfc296b747" providerId="LiveId" clId="{7F3DFCB6-D3EC-49C4-9130-F6BA86D7608E}" dt="2026-07-24T14:55:23.105" v="181" actId="20577"/>
         <pc:sldMkLst>
           <pc:docMk/>
           <pc:sldMk cId="0" sldId="262"/>
         </pc:sldMkLst>
         <pc:spChg chg="mod">
-          <ac:chgData name="Cliffin Cletus" userId="143810bfc296b747" providerId="LiveId" clId="{7F3DFCB6-D3EC-49C4-9130-F6BA86D7608E}" dt="2026-07-24T13:59:39.535" v="92" actId="1035"/>
+          <ac:chgData name="Cliffin Cletus" userId="143810bfc296b747" providerId="LiveId" clId="{7F3DFCB6-D3EC-49C4-9130-F6BA86D7608E}" dt="2026-07-24T14:55:23.105" v="181" actId="20577"/>
           <ac:spMkLst>
             <pc:docMk/>
             <pc:sldMk cId="0" sldId="262"/>
@@ -245,13 +245,13 @@
         </pc:spChg>
       </pc:sldChg>
       <pc:sldChg chg="modSp mod">
-        <pc:chgData name="Cliffin Cletus" userId="143810bfc296b747" providerId="LiveId" clId="{7F3DFCB6-D3EC-49C4-9130-F6BA86D7608E}" dt="2026-07-24T13:59:43.717" v="94" actId="27636"/>
+        <pc:chgData name="Cliffin Cletus" userId="143810bfc296b747" providerId="LiveId" clId="{7F3DFCB6-D3EC-49C4-9130-F6BA86D7608E}" dt="2026-07-24T14:55:08.673" v="175" actId="20577"/>
         <pc:sldMkLst>
           <pc:docMk/>
           <pc:sldMk cId="0" sldId="263"/>
         </pc:sldMkLst>
         <pc:spChg chg="mod">
-          <ac:chgData name="Cliffin Cletus" userId="143810bfc296b747" providerId="LiveId" clId="{7F3DFCB6-D3EC-49C4-9130-F6BA86D7608E}" dt="2026-07-24T13:59:43.717" v="94" actId="27636"/>
+          <ac:chgData name="Cliffin Cletus" userId="143810bfc296b747" providerId="LiveId" clId="{7F3DFCB6-D3EC-49C4-9130-F6BA86D7608E}" dt="2026-07-24T14:55:08.673" v="175" actId="20577"/>
           <ac:spMkLst>
             <pc:docMk/>
             <pc:sldMk cId="0" sldId="263"/>
@@ -260,13 +260,13 @@
         </pc:spChg>
       </pc:sldChg>
       <pc:sldChg chg="modSp mod">
-        <pc:chgData name="Cliffin Cletus" userId="143810bfc296b747" providerId="LiveId" clId="{7F3DFCB6-D3EC-49C4-9130-F6BA86D7608E}" dt="2026-07-24T13:59:47.775" v="96" actId="27636"/>
+        <pc:chgData name="Cliffin Cletus" userId="143810bfc296b747" providerId="LiveId" clId="{7F3DFCB6-D3EC-49C4-9130-F6BA86D7608E}" dt="2026-07-24T14:54:50.772" v="169" actId="14100"/>
         <pc:sldMkLst>
           <pc:docMk/>
           <pc:sldMk cId="0" sldId="264"/>
         </pc:sldMkLst>
         <pc:spChg chg="mod">
-          <ac:chgData name="Cliffin Cletus" userId="143810bfc296b747" providerId="LiveId" clId="{7F3DFCB6-D3EC-49C4-9130-F6BA86D7608E}" dt="2026-07-24T13:59:47.775" v="96" actId="27636"/>
+          <ac:chgData name="Cliffin Cletus" userId="143810bfc296b747" providerId="LiveId" clId="{7F3DFCB6-D3EC-49C4-9130-F6BA86D7608E}" dt="2026-07-24T14:54:50.772" v="169" actId="14100"/>
           <ac:spMkLst>
             <pc:docMk/>
             <pc:sldMk cId="0" sldId="264"/>
@@ -275,13 +275,13 @@
         </pc:spChg>
       </pc:sldChg>
       <pc:sldChg chg="modSp mod">
-        <pc:chgData name="Cliffin Cletus" userId="143810bfc296b747" providerId="LiveId" clId="{7F3DFCB6-D3EC-49C4-9130-F6BA86D7608E}" dt="2026-07-24T13:59:51.400" v="98" actId="27636"/>
+        <pc:chgData name="Cliffin Cletus" userId="143810bfc296b747" providerId="LiveId" clId="{7F3DFCB6-D3EC-49C4-9130-F6BA86D7608E}" dt="2026-07-24T14:54:37.032" v="160" actId="20577"/>
         <pc:sldMkLst>
           <pc:docMk/>
           <pc:sldMk cId="0" sldId="265"/>
         </pc:sldMkLst>
         <pc:spChg chg="mod">
-          <ac:chgData name="Cliffin Cletus" userId="143810bfc296b747" providerId="LiveId" clId="{7F3DFCB6-D3EC-49C4-9130-F6BA86D7608E}" dt="2026-07-24T13:59:51.400" v="98" actId="27636"/>
+          <ac:chgData name="Cliffin Cletus" userId="143810bfc296b747" providerId="LiveId" clId="{7F3DFCB6-D3EC-49C4-9130-F6BA86D7608E}" dt="2026-07-24T14:54:37.032" v="160" actId="20577"/>
           <ac:spMkLst>
             <pc:docMk/>
             <pc:sldMk cId="0" sldId="265"/>
@@ -290,19 +290,34 @@
         </pc:spChg>
       </pc:sldChg>
       <pc:sldChg chg="modSp mod">
-        <pc:chgData name="Cliffin Cletus" userId="143810bfc296b747" providerId="LiveId" clId="{7F3DFCB6-D3EC-49C4-9130-F6BA86D7608E}" dt="2026-07-24T13:59:54.895" v="100" actId="27636"/>
+        <pc:chgData name="Cliffin Cletus" userId="143810bfc296b747" providerId="LiveId" clId="{7F3DFCB6-D3EC-49C4-9130-F6BA86D7608E}" dt="2026-07-24T14:54:24.964" v="154" actId="20577"/>
         <pc:sldMkLst>
           <pc:docMk/>
           <pc:sldMk cId="0" sldId="266"/>
         </pc:sldMkLst>
         <pc:spChg chg="mod">
-          <ac:chgData name="Cliffin Cletus" userId="143810bfc296b747" providerId="LiveId" clId="{7F3DFCB6-D3EC-49C4-9130-F6BA86D7608E}" dt="2026-07-24T13:59:54.895" v="100" actId="27636"/>
+          <ac:chgData name="Cliffin Cletus" userId="143810bfc296b747" providerId="LiveId" clId="{7F3DFCB6-D3EC-49C4-9130-F6BA86D7608E}" dt="2026-07-24T14:53:53.755" v="148" actId="14100"/>
+          <ac:spMkLst>
+            <pc:docMk/>
+            <pc:sldMk cId="0" sldId="266"/>
+            <ac:spMk id="21" creationId="{00000000-0000-0000-0000-000000000000}"/>
+          </ac:spMkLst>
+        </pc:spChg>
+        <pc:spChg chg="mod">
+          <ac:chgData name="Cliffin Cletus" userId="143810bfc296b747" providerId="LiveId" clId="{7F3DFCB6-D3EC-49C4-9130-F6BA86D7608E}" dt="2026-07-24T14:54:24.964" v="154" actId="20577"/>
           <ac:spMkLst>
             <pc:docMk/>
             <pc:sldMk cId="0" sldId="266"/>
             <ac:spMk id="25" creationId="{00000000-0000-0000-0000-000000000000}"/>
           </ac:spMkLst>
         </pc:spChg>
+      </pc:sldChg>
+      <pc:sldChg chg="new del">
+        <pc:chgData name="Cliffin Cletus" userId="143810bfc296b747" providerId="LiveId" clId="{7F3DFCB6-D3EC-49C4-9130-F6BA86D7608E}" dt="2026-07-24T14:43:06.783" v="104" actId="2696"/>
+        <pc:sldMkLst>
+          <pc:docMk/>
+          <pc:sldMk cId="2189038385" sldId="267"/>
+        </pc:sldMkLst>
       </pc:sldChg>
     </pc:docChg>
   </pc:docChgLst>
@@ -2346,7 +2361,7 @@
         <p:spPr>
           <a:xfrm>
             <a:off x="2565648" y="9850946"/>
-            <a:ext cx="5968737" cy="300038"/>
+            <a:ext cx="7005072" cy="300038"/>
           </a:xfrm>
           <a:prstGeom prst="rect">
             <a:avLst/>
@@ -2374,7 +2389,7 @@
                 <a:ea typeface="Arial" pitchFamily="34" charset="-122"/>
                 <a:cs typeface="Arial" pitchFamily="34" charset="-120"/>
               </a:rPr>
-              <a:t>International Power &amp; Renewable Energy Conference</a:t>
+              <a:t>IEEE International Power &amp; Renewable Energy Conference</a:t>
             </a:r>
             <a:endParaRPr lang="en-US" sz="1800" dirty="0"/>
           </a:p>
@@ -3904,7 +3919,7 @@
         <p:spPr>
           <a:xfrm>
             <a:off x="2565648" y="9850946"/>
-            <a:ext cx="5968737" cy="300038"/>
+            <a:ext cx="7459638" cy="300038"/>
           </a:xfrm>
           <a:prstGeom prst="rect">
             <a:avLst/>
@@ -3932,7 +3947,7 @@
                 <a:ea typeface="Arial" pitchFamily="34" charset="-122"/>
                 <a:cs typeface="Arial" pitchFamily="34" charset="-120"/>
               </a:rPr>
-              <a:t>International Power &amp; Renewable Energy Conference</a:t>
+              <a:t>IEEE International Power &amp; Renewable Energy Conference</a:t>
             </a:r>
             <a:endParaRPr lang="en-US" sz="1800" dirty="0"/>
           </a:p>
@@ -4634,7 +4649,7 @@
         <p:spPr>
           <a:xfrm>
             <a:off x="7489850" y="6634163"/>
-            <a:ext cx="3943223" cy="366713"/>
+            <a:ext cx="6811366" cy="452438"/>
           </a:xfrm>
           <a:prstGeom prst="rect">
             <a:avLst/>
@@ -4644,7 +4659,7 @@
         </p:spPr>
         <p:txBody>
           <a:bodyPr wrap="square" lIns="25400" tIns="25400" rIns="25400" bIns="25400" rtlCol="0" anchor="t">
-            <a:normAutofit/>
+            <a:noAutofit/>
           </a:bodyPr>
           <a:lstStyle/>
           <a:p>
@@ -4660,7 +4675,7 @@
                 <a:ea typeface="Arial" pitchFamily="34" charset="-122"/>
                 <a:cs typeface="Arial" pitchFamily="34" charset="-120"/>
               </a:rPr>
-              <a:t>CoE Karunagappally, Kerala</a:t>
+              <a:t>College of Engineering Karunagappally, Kerala, India</a:t>
             </a:r>
             <a:endParaRPr lang="en-US" sz="2250" dirty="0"/>
           </a:p>
@@ -4768,7 +4783,7 @@
         <p:spPr>
           <a:xfrm>
             <a:off x="2565648" y="9850946"/>
-            <a:ext cx="5968737" cy="300038"/>
+            <a:ext cx="7797552" cy="300038"/>
           </a:xfrm>
           <a:prstGeom prst="rect">
             <a:avLst/>
@@ -4796,7 +4811,7 @@
                 <a:ea typeface="Arial" pitchFamily="34" charset="-122"/>
                 <a:cs typeface="Arial" pitchFamily="34" charset="-120"/>
               </a:rPr>
-              <a:t>International Power &amp; Renewable Energy Conference</a:t>
+              <a:t>IEEE International Power &amp; Renewable Energy Conference</a:t>
             </a:r>
             <a:endParaRPr lang="en-US" sz="1800" dirty="0"/>
           </a:p>
@@ -6456,7 +6471,7 @@
         </p:spPr>
         <p:txBody>
           <a:bodyPr wrap="square" lIns="25400" tIns="25400" rIns="25400" bIns="25400" rtlCol="0" anchor="t">
-            <a:normAutofit lnSpcReduction="10000"/>
+            <a:normAutofit fontScale="92500" lnSpcReduction="10000"/>
           </a:bodyPr>
           <a:lstStyle/>
           <a:p>
@@ -6474,7 +6489,7 @@
                 <a:ea typeface="Arial" pitchFamily="34" charset="-122"/>
                 <a:cs typeface="Arial" pitchFamily="34" charset="-120"/>
               </a:rPr>
-              <a:t>International Power &amp; Renewable Energy Conference</a:t>
+              <a:t>IEEE International Power &amp; Renewable Energy Conference</a:t>
             </a:r>
             <a:endParaRPr lang="en-US" sz="1800" dirty="0"/>
           </a:p>
@@ -7123,7 +7138,7 @@
         </p:spPr>
         <p:txBody>
           <a:bodyPr wrap="square" lIns="25400" tIns="25400" rIns="25400" bIns="25400" rtlCol="0" anchor="t">
-            <a:normAutofit lnSpcReduction="10000"/>
+            <a:normAutofit fontScale="92500" lnSpcReduction="10000"/>
           </a:bodyPr>
           <a:lstStyle/>
           <a:p>
@@ -7141,7 +7156,7 @@
                 <a:ea typeface="Arial" pitchFamily="34" charset="-122"/>
                 <a:cs typeface="Arial" pitchFamily="34" charset="-120"/>
               </a:rPr>
-              <a:t>International Power &amp; Renewable Energy Conference</a:t>
+              <a:t>IEEE International Power &amp; Renewable Energy Conference</a:t>
             </a:r>
             <a:endParaRPr lang="en-US" sz="1800" dirty="0"/>
           </a:p>
@@ -8164,7 +8179,7 @@
         <p:spPr>
           <a:xfrm>
             <a:off x="2565648" y="9850946"/>
-            <a:ext cx="5968737" cy="300038"/>
+            <a:ext cx="6675888" cy="300038"/>
           </a:xfrm>
           <a:prstGeom prst="rect">
             <a:avLst/>
@@ -8192,7 +8207,7 @@
                 <a:ea typeface="Arial" pitchFamily="34" charset="-122"/>
                 <a:cs typeface="Arial" pitchFamily="34" charset="-120"/>
               </a:rPr>
-              <a:t>International Power &amp; Renewable Energy Conference</a:t>
+              <a:t>IEEE International Power &amp; Renewable Energy Conference</a:t>
             </a:r>
             <a:endParaRPr lang="en-US" sz="1800" dirty="0"/>
           </a:p>
@@ -9452,7 +9467,7 @@
         <p:spPr>
           <a:xfrm>
             <a:off x="2565648" y="9850946"/>
-            <a:ext cx="5968737" cy="300038"/>
+            <a:ext cx="6456432" cy="300038"/>
           </a:xfrm>
           <a:prstGeom prst="rect">
             <a:avLst/>
@@ -9462,7 +9477,7 @@
         </p:spPr>
         <p:txBody>
           <a:bodyPr wrap="square" lIns="25400" tIns="25400" rIns="25400" bIns="25400" rtlCol="0" anchor="t">
-            <a:normAutofit lnSpcReduction="10000"/>
+            <a:normAutofit fontScale="92500" lnSpcReduction="10000"/>
           </a:bodyPr>
           <a:lstStyle/>
           <a:p>
@@ -9480,7 +9495,7 @@
                 <a:ea typeface="Arial" pitchFamily="34" charset="-122"/>
                 <a:cs typeface="Arial" pitchFamily="34" charset="-120"/>
               </a:rPr>
-              <a:t>International Power &amp; Renewable Energy Conference</a:t>
+              <a:t>IEEE International Power &amp; Renewable Energy Conference</a:t>
             </a:r>
             <a:endParaRPr lang="en-US" sz="1800" dirty="0"/>
           </a:p>
@@ -10371,7 +10386,7 @@
         <p:spPr>
           <a:xfrm>
             <a:off x="2565648" y="9850946"/>
-            <a:ext cx="5968737" cy="300038"/>
+            <a:ext cx="7297680" cy="300038"/>
           </a:xfrm>
           <a:prstGeom prst="rect">
             <a:avLst/>
@@ -10399,7 +10414,7 @@
                 <a:ea typeface="Arial" pitchFamily="34" charset="-122"/>
                 <a:cs typeface="Arial" pitchFamily="34" charset="-120"/>
               </a:rPr>
-              <a:t>International Power &amp; Renewable Energy Conference</a:t>
+              <a:t>IEEE International Power &amp; Renewable Energy Conference</a:t>
             </a:r>
             <a:endParaRPr lang="en-US" sz="1800" dirty="0"/>
           </a:p>
@@ -10992,7 +11007,7 @@
         <p:spPr>
           <a:xfrm>
             <a:off x="2565648" y="9850946"/>
-            <a:ext cx="5968737" cy="300038"/>
+            <a:ext cx="7139184" cy="300038"/>
           </a:xfrm>
           <a:prstGeom prst="rect">
             <a:avLst/>
@@ -11020,7 +11035,7 @@
                 <a:ea typeface="Arial" pitchFamily="34" charset="-122"/>
                 <a:cs typeface="Arial" pitchFamily="34" charset="-120"/>
               </a:rPr>
-              <a:t>International Power &amp; Renewable Energy Conference</a:t>
+              <a:t>IEEE International Power &amp; Renewable Energy Conference</a:t>
             </a:r>
             <a:endParaRPr lang="en-US" sz="1800" dirty="0"/>
           </a:p>
@@ -12243,7 +12258,7 @@
         <p:spPr>
           <a:xfrm>
             <a:off x="2565648" y="9850946"/>
-            <a:ext cx="5968737" cy="300038"/>
+            <a:ext cx="7029456" cy="300038"/>
           </a:xfrm>
           <a:prstGeom prst="rect">
             <a:avLst/>
@@ -12271,7 +12286,7 @@
                 <a:ea typeface="Arial" pitchFamily="34" charset="-122"/>
                 <a:cs typeface="Arial" pitchFamily="34" charset="-120"/>
               </a:rPr>
-              <a:t>International Power &amp; Renewable Energy Conference</a:t>
+              <a:t>IEEE International Power &amp; Renewable Energy Conference</a:t>
             </a:r>
             <a:endParaRPr lang="en-US" sz="1800" dirty="0"/>
           </a:p>
@@ -14264,7 +14279,7 @@
         <p:spPr>
           <a:xfrm>
             <a:off x="2565648" y="9850946"/>
-            <a:ext cx="5968737" cy="300038"/>
+            <a:ext cx="6724656" cy="300038"/>
           </a:xfrm>
           <a:prstGeom prst="rect">
             <a:avLst/>
@@ -14274,7 +14289,7 @@
         </p:spPr>
         <p:txBody>
           <a:bodyPr wrap="square" lIns="25400" tIns="25400" rIns="25400" bIns="25400" rtlCol="0" anchor="t">
-            <a:normAutofit lnSpcReduction="10000"/>
+            <a:normAutofit fontScale="92500" lnSpcReduction="10000"/>
           </a:bodyPr>
           <a:lstStyle/>
           <a:p>
@@ -14282,7 +14297,7 @@
               <a:buNone/>
             </a:pPr>
             <a:r>
-              <a:rPr lang="en-US" sz="1800" dirty="0">
+              <a:rPr lang="en-US" dirty="0">
                 <a:solidFill>
                   <a:srgbClr val="FFFFFF">
                     <a:alpha val="60000"/>
@@ -14292,7 +14307,20 @@
                 <a:ea typeface="Arial" pitchFamily="34" charset="-122"/>
                 <a:cs typeface="Arial" pitchFamily="34" charset="-120"/>
               </a:rPr>
-              <a:t>International Power &amp; Renewable Energy Conference</a:t>
+              <a:t>IEEE I</a:t>
+            </a:r>
+            <a:r>
+              <a:rPr lang="en-US" sz="1800" dirty="0">
+                <a:solidFill>
+                  <a:srgbClr val="FFFFFF">
+                    <a:alpha val="60000"/>
+                  </a:srgbClr>
+                </a:solidFill>
+                <a:latin typeface="Arial" pitchFamily="34" charset="0"/>
+                <a:ea typeface="Arial" pitchFamily="34" charset="-122"/>
+                <a:cs typeface="Arial" pitchFamily="34" charset="-120"/>
+              </a:rPr>
+              <a:t>nternational Power &amp; Renewable Energy Conference</a:t>
             </a:r>
             <a:endParaRPr lang="en-US" sz="1800" dirty="0"/>
           </a:p>

</xml_diff>